<commit_message>
Update executive overview deck
Co-Authored-By: Claude Opus 4.6 (1M context) <noreply@anthropic.com>
</commit_message>
<xml_diff>
--- a/decks/SLG-Agentic-AI-Suite-Executive-Overview.pptx
+++ b/decks/SLG-Agentic-AI-Suite-Executive-Overview.pptx
@@ -507,7 +507,9 @@
           <a:p>
             <a:r>
               <a:rPr lang="en-US" dirty="0"/>
-              <a:t/>
+              <a:t>TIMING ~1 min.
+SHOW: the title — Agentic AI for State &amp; Local Government, an executive overview for CIOs, CISOs, and directors of architecture.
+SAY: 'In ~15 minutes I'll show you eight governed AI agents and an optional whole-of-government platform — all AWS-native, all deployable standalone, and built so a CISO can defend them. The theme: the agent isn't the product; the governance that makes it deployable is.'</a:t>
             </a:r>
             <a:endParaRPr lang="en-US" dirty="0"/>
           </a:p>
@@ -595,7 +597,10 @@
           <a:p>
             <a:r>
               <a:rPr lang="en-US" dirty="0"/>
-              <a:t/>
+              <a:t>TIMING ~2.5 min.
+SHOW: the four stat cards — AI is the #1 state-CIO priority, 90% of states piloting GenAI, only 25% funded, ADA Title II deadlines 2027-28.
+SAY: 'AI just became the number-one state-CIO priority for 2026, displacing cybersecurity. But 90% of states are stuck in pilots and only a quarter have funding — and ADA Title II now puts AI-generated output on a compliance clock.'
+LAND IT: 'The gap between a pilot and production isn't the model — it's governance: identity, authorization, audit, retention, accessibility. That gap is exactly what this closes.'</a:t>
             </a:r>
             <a:endParaRPr lang="en-US" dirty="0"/>
           </a:p>
@@ -683,7 +688,10 @@
           <a:p>
             <a:r>
               <a:rPr lang="en-US" dirty="0"/>
-              <a:t/>
+              <a:t>TIMING ~3 min.
+SHOW: the 4x2 portfolio grid of the eight agents.
+SAY: 'Eight agents across the highest-value workflows — resident services, forms, permitting, benefits, public records, procurement, IT service desk, and public safety/health. Pick the one or two that match this customer's pain and go deep there in the per-agent deck.'
+EMPHASIZE the footer: 'Each agent prepares; a human owns every legally consequential decision — issue a permit, adjudicate eligibility, release records, award a contract — and that's withheld in code, not just policy. A passing test proves it.'</a:t>
             </a:r>
             <a:endParaRPr lang="en-US" dirty="0"/>
           </a:p>
@@ -771,7 +779,10 @@
           <a:p>
             <a:r>
               <a:rPr lang="en-US" dirty="0"/>
-              <a:t/>
+              <a:t>TIMING ~3 min.
+SHOW: the four platform pillars on the navy slide.
+SAY: 'Here's why this is different. The deny-by-default gateway means an agent can never exceed the employee it acts for. The human gate is framework-enforced, not documented. It's regulated by design — WORM retention, KMS, data-class isolation, mapped to CJIS, IRS 1075, HIPAA, FERPA, DPPA, ADA, GovRAMP and NIST AI RMF. And it deploys on AWS, commercial and GovCloud.'
+SOUNDBITE: 'A control improvement here — the masker, the audit, grounding — benefits all eight agents at once. Controls compound instead of multiplying audits.'</a:t>
             </a:r>
             <a:endParaRPr lang="en-US" dirty="0"/>
           </a:p>
@@ -859,7 +870,10 @@
           <a:p>
             <a:r>
               <a:rPr lang="en-US" dirty="0"/>
-              <a:t/>
+              <a:t>TIMING ~2.5 min.
+SHOW: the four Whole-of-Government cards — canonical data, consent &amp; identity, compliance event bus, life-event orchestrator.
+SAY: 'The strategic layer organizes government around life events — moving, a new child, starting a business, losing a job, a disaster, a death in the family — not the org chart. A durable saga coordinates the agencies; if a downstream step fails, completed steps roll back, so nobody is left half-enrolled. Five life-events run today.'
+FRAME: 'This is additive — agents deploy standalone first; the platform is the long game that turns dozens of demos into digital government.'</a:t>
             </a:r>
             <a:endParaRPr lang="en-US" dirty="0"/>
           </a:p>
@@ -947,7 +961,10 @@
           <a:p>
             <a:r>
               <a:rPr lang="en-US" dirty="0"/>
-              <a:t/>
+              <a:t>TIMING ~2 min + close.
+SHOW: the four engagement cards.
+SAY: 'This is a credible starting point, not a science project: it runs today with no API key and 179 passing governance tests; it ships as CloudFormation and Terraform for commercial and GovCloud; and it comes with field-ready collateral — per-agent decks, ROI, compliance mappings, runbooks, and a seller/SA field guide.'
+THE ASK: 'Let's pick one agency and one workflow, stand it up in your account, and put a real, cross-agency audit trail in front of your CISO. Everything you saw already runs — the pilot just points it at your systems.'</a:t>
             </a:r>
             <a:endParaRPr lang="en-US" dirty="0"/>
           </a:p>
@@ -4391,7 +4408,7 @@
                   <a:srgbClr val="CADCFC"/>
                 </a:solidFill>
               </a:rPr>
-              <a:t>64 automated tests pass with no API key; deterministic demo before any AWS spend.</a:t>
+              <a:t>179 automated tests pass with no API key; deterministic demo before any AWS spend.</a:t>
             </a:r>
             <a:endParaRPr lang="en-US" sz="1300" dirty="0"/>
           </a:p>

</xml_diff>